<commit_message>
Migrate data layer to Cloud Firestore; add Firebase setup, manual & updated docs
- Replace shared_preferences with firebase_core + cloud_firestore
- Add lib/firebase_options.dart (web) for the shared Firebase project
- Realtime snapshot listener for transactions; budget in settings/app
- Update tests to use fake_cloud_firestore (12 passing)
- Update README, project report and slides to reflect Firebase
- Add docs/USER_MANUAL.md (setup & demo guide for the team)
</commit_message>
<xml_diff>
--- a/docs/My_Wallet_Presentation.pptx
+++ b/docs/My_Wallet_Presentation.pptx
@@ -3266,7 +3266,7 @@
                 </a:solidFill>
                 <a:latin typeface="Calibri"/>
               </a:rPr>
-              <a:t>A cross-platform CRUD mobile app built with Flutter</a:t>
+              <a:t>A cross-platform CRUD mobile app built with Flutter &amp; Firebase</a:t>
             </a:r>
           </a:p>
         </p:txBody>
@@ -3352,7 +3352,7 @@
                 </a:solidFill>
                 <a:latin typeface="Calibri"/>
               </a:rPr>
-              <a:t>Mobile Application Development  ·  Project Pitch &amp; Demo</a:t>
+              <a:t>DES3113 — Mobile App Design &amp; Development  ·  Pitch &amp; Demo</a:t>
             </a:r>
           </a:p>
           <a:p>
@@ -3371,7 +3371,7 @@
                 </a:solidFill>
                 <a:latin typeface="Calibri"/>
               </a:rPr>
-              <a:t>Group [Name]  ·  Members 1–5  ·  June 2026</a:t>
+              <a:t>Team of 5  ·  Lecturer: Dr. Ahmad Wiraputra bin Selamat  ·  2026</a:t>
             </a:r>
           </a:p>
         </p:txBody>
@@ -4400,7 +4400,7 @@
                 </a:solidFill>
                 <a:latin typeface="Trebuchet MS"/>
               </a:rPr>
-              <a:t>11 / 11</a:t>
+              <a:t>12 / 12</a:t>
             </a:r>
           </a:p>
         </p:txBody>
@@ -4712,7 +4712,7 @@
                 </a:solidFill>
                 <a:latin typeface="Calibri"/>
               </a:rPr>
-              <a:t>add · update · delete · clearAll · budget · totals.</a:t>
+              <a:t>CRUD + budget on an in-memory test database.</a:t>
             </a:r>
           </a:p>
         </p:txBody>
@@ -4940,7 +4940,7 @@
                 </a:solidFill>
                 <a:latin typeface="Calibri"/>
               </a:rPr>
-              <a:t>8 end-to-end flows incl. persistence after restart.</a:t>
+              <a:t>9 flows incl. data appearing live in the Firebase console.</a:t>
             </a:r>
           </a:p>
         </p:txBody>
@@ -5210,7 +5210,7 @@
         <p:spPr>
           <a:xfrm>
             <a:off x="1783080" y="1645920"/>
-            <a:ext cx="3657600" cy="713232"/>
+            <a:ext cx="4663440" cy="713232"/>
           </a:xfrm>
           <a:prstGeom prst="rect">
             <a:avLst/>
@@ -5232,13 +5232,13 @@
               </a:spcAft>
             </a:pPr>
             <a:r>
-              <a:rPr sz="1500" b="1" i="0">
+              <a:rPr sz="1250" b="1" i="0">
                 <a:solidFill>
                   <a:srgbClr val="222222"/>
                 </a:solidFill>
                 <a:latin typeface="Calibri"/>
               </a:rPr>
-              <a:t>Member 1</a:t>
+              <a:t>Sazit Ul Islam</a:t>
             </a:r>
           </a:p>
         </p:txBody>
@@ -5251,8 +5251,8 @@
         </p:nvSpPr>
         <p:spPr>
           <a:xfrm>
-            <a:off x="5120640" y="1645920"/>
-            <a:ext cx="6035040" cy="713232"/>
+            <a:off x="6583680" y="1645920"/>
+            <a:ext cx="4572000" cy="713232"/>
           </a:xfrm>
           <a:prstGeom prst="rect">
             <a:avLst/>
@@ -5274,7 +5274,7 @@
               </a:spcAft>
             </a:pPr>
             <a:r>
-              <a:rPr sz="1350" b="0" i="0">
+              <a:rPr sz="1200" b="0" i="0">
                 <a:solidFill>
                   <a:srgbClr val="6B6B6B"/>
                 </a:solidFill>
@@ -5395,7 +5395,7 @@
         <p:spPr>
           <a:xfrm>
             <a:off x="1783080" y="2487168"/>
-            <a:ext cx="3657600" cy="713232"/>
+            <a:ext cx="4663440" cy="713232"/>
           </a:xfrm>
           <a:prstGeom prst="rect">
             <a:avLst/>
@@ -5417,13 +5417,13 @@
               </a:spcAft>
             </a:pPr>
             <a:r>
-              <a:rPr sz="1500" b="1" i="0">
+              <a:rPr sz="1250" b="1" i="0">
                 <a:solidFill>
                   <a:srgbClr val="222222"/>
                 </a:solidFill>
                 <a:latin typeface="Calibri"/>
               </a:rPr>
-              <a:t>Member 2</a:t>
+              <a:t>Nur Aisyatul Najwa binti Mohamad Nasir</a:t>
             </a:r>
           </a:p>
         </p:txBody>
@@ -5436,8 +5436,8 @@
         </p:nvSpPr>
         <p:spPr>
           <a:xfrm>
-            <a:off x="5120640" y="2487168"/>
-            <a:ext cx="6035040" cy="713232"/>
+            <a:off x="6583680" y="2487168"/>
+            <a:ext cx="4572000" cy="713232"/>
           </a:xfrm>
           <a:prstGeom prst="rect">
             <a:avLst/>
@@ -5459,7 +5459,7 @@
               </a:spcAft>
             </a:pPr>
             <a:r>
-              <a:rPr sz="1350" b="0" i="0">
+              <a:rPr sz="1200" b="0" i="0">
                 <a:solidFill>
                   <a:srgbClr val="6B6B6B"/>
                 </a:solidFill>
@@ -5578,7 +5578,7 @@
         <p:spPr>
           <a:xfrm>
             <a:off x="1783080" y="3328416"/>
-            <a:ext cx="3657600" cy="713232"/>
+            <a:ext cx="4663440" cy="713232"/>
           </a:xfrm>
           <a:prstGeom prst="rect">
             <a:avLst/>
@@ -5600,13 +5600,13 @@
               </a:spcAft>
             </a:pPr>
             <a:r>
-              <a:rPr sz="1500" b="1" i="0">
+              <a:rPr sz="1250" b="1" i="0">
                 <a:solidFill>
                   <a:srgbClr val="222222"/>
                 </a:solidFill>
                 <a:latin typeface="Calibri"/>
               </a:rPr>
-              <a:t>Member 3</a:t>
+              <a:t>Nurfatin Aqilah binti Zolkifli</a:t>
             </a:r>
           </a:p>
         </p:txBody>
@@ -5619,8 +5619,8 @@
         </p:nvSpPr>
         <p:spPr>
           <a:xfrm>
-            <a:off x="5120640" y="3328416"/>
-            <a:ext cx="6035040" cy="713232"/>
+            <a:off x="6583680" y="3328416"/>
+            <a:ext cx="4572000" cy="713232"/>
           </a:xfrm>
           <a:prstGeom prst="rect">
             <a:avLst/>
@@ -5642,7 +5642,7 @@
               </a:spcAft>
             </a:pPr>
             <a:r>
-              <a:rPr sz="1350" b="0" i="0">
+              <a:rPr sz="1200" b="0" i="0">
                 <a:solidFill>
                   <a:srgbClr val="6B6B6B"/>
                 </a:solidFill>
@@ -5763,7 +5763,7 @@
         <p:spPr>
           <a:xfrm>
             <a:off x="1783080" y="4169664"/>
-            <a:ext cx="3657600" cy="713232"/>
+            <a:ext cx="4663440" cy="713232"/>
           </a:xfrm>
           <a:prstGeom prst="rect">
             <a:avLst/>
@@ -5785,13 +5785,13 @@
               </a:spcAft>
             </a:pPr>
             <a:r>
-              <a:rPr sz="1500" b="1" i="0">
+              <a:rPr sz="1250" b="1" i="0">
                 <a:solidFill>
                   <a:srgbClr val="222222"/>
                 </a:solidFill>
                 <a:latin typeface="Calibri"/>
               </a:rPr>
-              <a:t>Member 4</a:t>
+              <a:t>Shi Kaiyan</a:t>
             </a:r>
           </a:p>
         </p:txBody>
@@ -5804,8 +5804,8 @@
         </p:nvSpPr>
         <p:spPr>
           <a:xfrm>
-            <a:off x="5120640" y="4169664"/>
-            <a:ext cx="6035040" cy="713232"/>
+            <a:off x="6583680" y="4169664"/>
+            <a:ext cx="4572000" cy="713232"/>
           </a:xfrm>
           <a:prstGeom prst="rect">
             <a:avLst/>
@@ -5827,13 +5827,13 @@
               </a:spcAft>
             </a:pPr>
             <a:r>
-              <a:rPr sz="1350" b="0" i="0">
+              <a:rPr sz="1200" b="0" i="0">
                 <a:solidFill>
                   <a:srgbClr val="6B6B6B"/>
                 </a:solidFill>
                 <a:latin typeface="Calibri"/>
               </a:rPr>
-              <a:t>Discover, Profile · Persistence &amp; testing</a:t>
+              <a:t>Discover, Profile · Firebase &amp; testing</a:t>
             </a:r>
           </a:p>
         </p:txBody>
@@ -5946,7 +5946,7 @@
         <p:spPr>
           <a:xfrm>
             <a:off x="1783080" y="5010912"/>
-            <a:ext cx="3657600" cy="713232"/>
+            <a:ext cx="4663440" cy="713232"/>
           </a:xfrm>
           <a:prstGeom prst="rect">
             <a:avLst/>
@@ -5968,13 +5968,13 @@
               </a:spcAft>
             </a:pPr>
             <a:r>
-              <a:rPr sz="1500" b="1" i="0">
+              <a:rPr sz="1250" b="1" i="0">
                 <a:solidFill>
                   <a:srgbClr val="222222"/>
                 </a:solidFill>
                 <a:latin typeface="Calibri"/>
               </a:rPr>
-              <a:t>Member 5</a:t>
+              <a:t>Mst Samiya Haque Kotha</a:t>
             </a:r>
           </a:p>
         </p:txBody>
@@ -5987,8 +5987,8 @@
         </p:nvSpPr>
         <p:spPr>
           <a:xfrm>
-            <a:off x="5120640" y="5010912"/>
-            <a:ext cx="6035040" cy="713232"/>
+            <a:off x="6583680" y="5010912"/>
+            <a:ext cx="4572000" cy="713232"/>
           </a:xfrm>
           <a:prstGeom prst="rect">
             <a:avLst/>
@@ -6010,7 +6010,7 @@
               </a:spcAft>
             </a:pPr>
             <a:r>
-              <a:rPr sz="1350" b="0" i="0">
+              <a:rPr sz="1200" b="0" i="0">
                 <a:solidFill>
                   <a:srgbClr val="6B6B6B"/>
                 </a:solidFill>
@@ -6447,7 +6447,7 @@
                 </a:solidFill>
                 <a:latin typeface="Calibri"/>
               </a:rPr>
-              <a:t>Structured storage → JSON + prefs</a:t>
+              <a:t>Cloud data → Firestore + realtime listener</a:t>
             </a:r>
           </a:p>
         </p:txBody>
@@ -6774,7 +6774,7 @@
                 </a:solidFill>
                 <a:latin typeface="Calibri"/>
               </a:rPr>
-              <a:t>Cloud sync &amp; multi-device</a:t>
+              <a:t>User accounts (Firebase Auth)</a:t>
             </a:r>
           </a:p>
         </p:txBody>
@@ -6869,7 +6869,7 @@
                 </a:solidFill>
                 <a:latin typeface="Calibri"/>
               </a:rPr>
-              <a:t>Export to CSV / PDF</a:t>
+              <a:t>Firestore security rules</a:t>
             </a:r>
           </a:p>
         </p:txBody>
@@ -6964,7 +6964,7 @@
                 </a:solidFill>
                 <a:latin typeface="Calibri"/>
               </a:rPr>
-              <a:t>Recurring bills &amp; reminders</a:t>
+              <a:t>Export to CSV / PDF</a:t>
             </a:r>
           </a:p>
         </p:txBody>
@@ -7059,7 +7059,7 @@
                 </a:solidFill>
                 <a:latin typeface="Calibri"/>
               </a:rPr>
-              <a:t>Dark mode &amp; multi-currency</a:t>
+              <a:t>Recurring bills &amp; reminders</a:t>
             </a:r>
           </a:p>
         </p:txBody>
@@ -7154,7 +7154,7 @@
                 </a:solidFill>
                 <a:latin typeface="Calibri"/>
               </a:rPr>
-              <a:t>SQLite for larger datasets</a:t>
+              <a:t>Dark mode &amp; multi-currency</a:t>
             </a:r>
           </a:p>
         </p:txBody>
@@ -7342,7 +7342,7 @@
                 </a:solidFill>
                 <a:latin typeface="Calibri"/>
               </a:rPr>
-              <a:t>Built with Flutter  ·  Provider  ·  shared_preferences</a:t>
+              <a:t>Built with Flutter  ·  Firebase  ·  Cloud Firestore</a:t>
             </a:r>
           </a:p>
         </p:txBody>
@@ -7384,7 +7384,7 @@
                 </a:solidFill>
                 <a:latin typeface="Calibri"/>
               </a:rPr>
-              <a:t>Questions &amp; demo  ·  github.com/[your-repo]</a:t>
+              <a:t>Questions &amp; demo  ·  github.com/LBBT-God/expense-tracker</a:t>
             </a:r>
           </a:p>
         </p:txBody>
@@ -7605,7 +7605,7 @@
                 </a:solidFill>
                 <a:latin typeface="Calibri"/>
               </a:rPr>
-              <a:t>Small, frequent purchases are easy to forget and quickly add up. Most finance apps are cluttered, ad-heavy, or force the user to create an online account and hand over their data.</a:t>
+              <a:t>Small, frequent purchases are easy to forget and quickly add up. Most finance apps are cluttered, ad-heavy, or hide the basics behind a paywall.</a:t>
             </a:r>
           </a:p>
         </p:txBody>
@@ -7886,7 +7886,7 @@
                 </a:solidFill>
                 <a:latin typeface="Trebuchet MS"/>
               </a:rPr>
-              <a:t>🔒</a:t>
+              <a:t>💾</a:t>
             </a:r>
           </a:p>
         </p:txBody>
@@ -7928,7 +7928,7 @@
                 </a:solidFill>
                 <a:latin typeface="Calibri"/>
               </a:rPr>
-              <a:t>Privacy worries</a:t>
+              <a:t>No backup</a:t>
             </a:r>
           </a:p>
           <a:p>
@@ -7947,7 +7947,7 @@
                 </a:solidFill>
                 <a:latin typeface="Calibri"/>
               </a:rPr>
-              <a:t>Users don't want finances pushed to the cloud.</a:t>
+              <a:t>Records trapped on one phone — lost if it's gone.</a:t>
             </a:r>
           </a:p>
         </p:txBody>
@@ -8260,7 +8260,7 @@
                 </a:solidFill>
                 <a:latin typeface="Trebuchet MS"/>
               </a:rPr>
-              <a:t>A fast, private, on-device ledger</a:t>
+              <a:t>A fast, simple, cloud-backed ledger</a:t>
             </a:r>
           </a:p>
           <a:p>
@@ -8282,7 +8282,7 @@
                 </a:solidFill>
                 <a:latin typeface="Calibri"/>
               </a:rPr>
-              <a:t>My Wallet lets you record income and expenses in seconds, browse them by day and month, see spending trends, and stay on budget — with every record stored privately on your own device.</a:t>
+              <a:t>My Wallet lets you record income and expenses in seconds, browse them by day and month, see spending trends, and stay on budget — with every record stored safely in the cloud and synced in realtime.</a:t>
             </a:r>
           </a:p>
         </p:txBody>
@@ -8757,7 +8757,7 @@
                 </a:solidFill>
                 <a:latin typeface="Calibri"/>
               </a:rPr>
-              <a:t>100% offline — no account, no cloud</a:t>
+              <a:t>Realtime cloud sync with Firebase</a:t>
             </a:r>
           </a:p>
         </p:txBody>
@@ -9956,7 +9956,7 @@
                 </a:solidFill>
                 <a:latin typeface="Trebuchet MS"/>
               </a:rPr>
-              <a:t>💾</a:t>
+              <a:t>☁️</a:t>
             </a:r>
           </a:p>
         </p:txBody>
@@ -9998,7 +9998,7 @@
                 </a:solidFill>
                 <a:latin typeface="Calibri"/>
               </a:rPr>
-              <a:t>Local Storage</a:t>
+              <a:t>Cloud Database</a:t>
             </a:r>
           </a:p>
           <a:p>
@@ -10020,7 +10020,7 @@
                 </a:solidFill>
                 <a:latin typeface="Calibri"/>
               </a:rPr>
-              <a:t>Saved on-device with shared_preferences.</a:t>
+              <a:t>Stored in Cloud Firestore, synced in realtime.</a:t>
             </a:r>
           </a:p>
         </p:txBody>
@@ -11624,7 +11624,7 @@
                 </a:solidFill>
                 <a:latin typeface="Calibri"/>
               </a:rPr>
-              <a:t>↓  toJson / fromJson</a:t>
+              <a:t>↓  toMap / fromMap</a:t>
             </a:r>
           </a:p>
         </p:txBody>
@@ -11763,7 +11763,7 @@
                 </a:solidFill>
                 <a:latin typeface="Calibri"/>
               </a:rPr>
-              <a:t>↓  load / save</a:t>
+              <a:t>↓  snapshots / set / delete</a:t>
             </a:r>
           </a:p>
         </p:txBody>
@@ -11860,7 +11860,7 @@
                 </a:solidFill>
                 <a:latin typeface="Calibri"/>
               </a:rPr>
-              <a:t>SharedPreferences  (local JSON key/value)</a:t>
+              <a:t>Cloud Firestore  (realtime NoSQL database)</a:t>
             </a:r>
           </a:p>
         </p:txBody>
@@ -12024,7 +12024,7 @@
                 </a:solidFill>
                 <a:latin typeface="Calibri"/>
               </a:rPr>
-              <a:t>• No network needed</a:t>
+              <a:t>• Realtime cloud sync</a:t>
             </a:r>
           </a:p>
         </p:txBody>
@@ -12627,7 +12627,7 @@
                 </a:solidFill>
                 <a:latin typeface="Trebuchet MS"/>
               </a:rPr>
-              <a:t>provider</a:t>
+              <a:t>firebase_core</a:t>
             </a:r>
           </a:p>
           <a:p>
@@ -12649,7 +12649,7 @@
                 </a:solidFill>
                 <a:latin typeface="Calibri"/>
               </a:rPr>
-              <a:t>ChangeNotifier state management</a:t>
+              <a:t>Firebase initialisation</a:t>
             </a:r>
           </a:p>
         </p:txBody>
@@ -12783,7 +12783,7 @@
                 </a:solidFill>
                 <a:latin typeface="Trebuchet MS"/>
               </a:rPr>
-              <a:t>shared_preferences</a:t>
+              <a:t>cloud_firestore</a:t>
             </a:r>
           </a:p>
           <a:p>
@@ -12805,7 +12805,7 @@
                 </a:solidFill>
                 <a:latin typeface="Calibri"/>
               </a:rPr>
-              <a:t>Local on-device persistence</a:t>
+              <a:t>Realtime cloud database (CRUD)</a:t>
             </a:r>
           </a:p>
         </p:txBody>
@@ -12939,7 +12939,7 @@
                 </a:solidFill>
                 <a:latin typeface="Trebuchet MS"/>
               </a:rPr>
-              <a:t>intl</a:t>
+              <a:t>provider</a:t>
             </a:r>
           </a:p>
           <a:p>
@@ -12961,7 +12961,7 @@
                 </a:solidFill>
                 <a:latin typeface="Calibri"/>
               </a:rPr>
-              <a:t>Date &amp; number formatting</a:t>
+              <a:t>ChangeNotifier state management</a:t>
             </a:r>
           </a:p>
         </p:txBody>
@@ -13095,7 +13095,7 @@
                 </a:solidFill>
                 <a:latin typeface="Trebuchet MS"/>
               </a:rPr>
-              <a:t>uuid</a:t>
+              <a:t>intl · uuid</a:t>
             </a:r>
           </a:p>
           <a:p>
@@ -13117,7 +13117,7 @@
                 </a:solidFill>
                 <a:latin typeface="Calibri"/>
               </a:rPr>
-              <a:t>Unique transaction IDs</a:t>
+              <a:t>Formatting &amp; unique IDs</a:t>
             </a:r>
           </a:p>
         </p:txBody>
@@ -13669,7 +13669,7 @@
                 </a:solidFill>
                 <a:latin typeface="Trebuchet MS"/>
               </a:rPr>
-              <a:t>On-device persistence</a:t>
+              <a:t>Cloud persistence</a:t>
             </a:r>
           </a:p>
           <a:p>
@@ -13691,7 +13691,7 @@
                 </a:solidFill>
                 <a:latin typeface="Calibri"/>
               </a:rPr>
-              <a:t>Transactions are serialised to JSON and saved as a string list with shared_preferences — lightweight and fully offline.</a:t>
+              <a:t>Each transaction is a document in Cloud Firestore. A realtime snapshot listener streams changes back, so the UI updates instantly across devices.</a:t>
             </a:r>
           </a:p>
         </p:txBody>
@@ -13772,11 +13772,27 @@
             <a:r>
               <a:rPr sz="1150">
                 <a:solidFill>
+                  <a:srgbClr val="BDBDBD"/>
+                </a:solidFill>
+                <a:latin typeface="Consolas"/>
+              </a:rPr>
+              <a:t>// Realtime read</a:t>
+            </a:r>
+          </a:p>
+          <a:p>
+            <a:pPr>
+              <a:spcAft>
+                <a:spcPts val="100"/>
+              </a:spcAft>
+            </a:pPr>
+            <a:r>
+              <a:rPr sz="1150">
+                <a:solidFill>
                   <a:srgbClr val="FFC107"/>
                 </a:solidFill>
                 <a:latin typeface="Consolas"/>
               </a:rPr>
-              <a:t>Future&lt;void&gt; add(Transaction t) async {</a:t>
+              <a:t>_txCol.snapshots().listen((snap) {</a:t>
             </a:r>
           </a:p>
           <a:p>
@@ -13792,7 +13808,7 @@
                 </a:solidFill>
                 <a:latin typeface="Consolas"/>
               </a:rPr>
-              <a:t>  _transactions.add(t);</a:t>
+              <a:t>  _transactions = snap.docs</a:t>
             </a:r>
           </a:p>
           <a:p>
@@ -13808,7 +13824,7 @@
                 </a:solidFill>
                 <a:latin typeface="Consolas"/>
               </a:rPr>
-              <a:t>  await _save();</a:t>
+              <a:t>      .map((d) =&gt;</a:t>
             </a:r>
           </a:p>
           <a:p>
@@ -13824,6 +13840,38 @@
                 </a:solidFill>
                 <a:latin typeface="Consolas"/>
               </a:rPr>
+              <a:t>          Transaction.fromMap(d.data()))</a:t>
+            </a:r>
+          </a:p>
+          <a:p>
+            <a:pPr>
+              <a:spcAft>
+                <a:spcPts val="100"/>
+              </a:spcAft>
+            </a:pPr>
+            <a:r>
+              <a:rPr sz="1150">
+                <a:solidFill>
+                  <a:srgbClr val="FFFFFF"/>
+                </a:solidFill>
+                <a:latin typeface="Consolas"/>
+              </a:rPr>
+              <a:t>      .toList();</a:t>
+            </a:r>
+          </a:p>
+          <a:p>
+            <a:pPr>
+              <a:spcAft>
+                <a:spcPts val="100"/>
+              </a:spcAft>
+            </a:pPr>
+            <a:r>
+              <a:rPr sz="1150">
+                <a:solidFill>
+                  <a:srgbClr val="FFFFFF"/>
+                </a:solidFill>
+                <a:latin typeface="Consolas"/>
+              </a:rPr>
               <a:t>  notifyListeners();</a:t>
             </a:r>
           </a:p>
@@ -13840,7 +13888,7 @@
                 </a:solidFill>
                 <a:latin typeface="Consolas"/>
               </a:rPr>
-              <a:t>}</a:t>
+              <a:t>});</a:t>
             </a:r>
           </a:p>
           <a:p>
@@ -13868,11 +13916,11 @@
             <a:r>
               <a:rPr sz="1150">
                 <a:solidFill>
-                  <a:srgbClr val="FFC107"/>
+                  <a:srgbClr val="BDBDBD"/>
                 </a:solidFill>
                 <a:latin typeface="Consolas"/>
               </a:rPr>
-              <a:t>Future&lt;void&gt; _save() async {</a:t>
+              <a:t>// Create / Update</a:t>
             </a:r>
           </a:p>
           <a:p>
@@ -13888,7 +13936,7 @@
                 </a:solidFill>
                 <a:latin typeface="Consolas"/>
               </a:rPr>
-              <a:t>  final prefs =</a:t>
+              <a:t>await _txCol.doc(t.id).set(t.toMap());</a:t>
             </a:r>
           </a:p>
           <a:p>
@@ -13904,7 +13952,7 @@
                 </a:solidFill>
                 <a:latin typeface="Consolas"/>
               </a:rPr>
-              <a:t>      await SharedPreferences.getInstance();</a:t>
+              <a:t> </a:t>
             </a:r>
           </a:p>
           <a:p>
@@ -13916,91 +13964,27 @@
             <a:r>
               <a:rPr sz="1150">
                 <a:solidFill>
+                  <a:srgbClr val="BDBDBD"/>
+                </a:solidFill>
+                <a:latin typeface="Consolas"/>
+              </a:rPr>
+              <a:t>// Delete</a:t>
+            </a:r>
+          </a:p>
+          <a:p>
+            <a:pPr>
+              <a:spcAft>
+                <a:spcPts val="100"/>
+              </a:spcAft>
+            </a:pPr>
+            <a:r>
+              <a:rPr sz="1150">
+                <a:solidFill>
                   <a:srgbClr val="FFFFFF"/>
                 </a:solidFill>
                 <a:latin typeface="Consolas"/>
               </a:rPr>
-              <a:t>  await prefs.setStringList(</a:t>
-            </a:r>
-          </a:p>
-          <a:p>
-            <a:pPr>
-              <a:spcAft>
-                <a:spcPts val="100"/>
-              </a:spcAft>
-            </a:pPr>
-            <a:r>
-              <a:rPr sz="1150">
-                <a:solidFill>
-                  <a:srgbClr val="BDBDBD"/>
-                </a:solidFill>
-                <a:latin typeface="Consolas"/>
-              </a:rPr>
-              <a:t>    'transactions',</a:t>
-            </a:r>
-          </a:p>
-          <a:p>
-            <a:pPr>
-              <a:spcAft>
-                <a:spcPts val="100"/>
-              </a:spcAft>
-            </a:pPr>
-            <a:r>
-              <a:rPr sz="1150">
-                <a:solidFill>
-                  <a:srgbClr val="FFFFFF"/>
-                </a:solidFill>
-                <a:latin typeface="Consolas"/>
-              </a:rPr>
-              <a:t>    _transactions.map((t) =&gt; t.toJson())</a:t>
-            </a:r>
-          </a:p>
-          <a:p>
-            <a:pPr>
-              <a:spcAft>
-                <a:spcPts val="100"/>
-              </a:spcAft>
-            </a:pPr>
-            <a:r>
-              <a:rPr sz="1150">
-                <a:solidFill>
-                  <a:srgbClr val="FFFFFF"/>
-                </a:solidFill>
-                <a:latin typeface="Consolas"/>
-              </a:rPr>
-              <a:t>        .toList(),</a:t>
-            </a:r>
-          </a:p>
-          <a:p>
-            <a:pPr>
-              <a:spcAft>
-                <a:spcPts val="100"/>
-              </a:spcAft>
-            </a:pPr>
-            <a:r>
-              <a:rPr sz="1150">
-                <a:solidFill>
-                  <a:srgbClr val="FFFFFF"/>
-                </a:solidFill>
-                <a:latin typeface="Consolas"/>
-              </a:rPr>
-              <a:t>  );</a:t>
-            </a:r>
-          </a:p>
-          <a:p>
-            <a:pPr>
-              <a:spcAft>
-                <a:spcPts val="100"/>
-              </a:spcAft>
-            </a:pPr>
-            <a:r>
-              <a:rPr sz="1150">
-                <a:solidFill>
-                  <a:srgbClr val="FFC107"/>
-                </a:solidFill>
-                <a:latin typeface="Consolas"/>
-              </a:rPr>
-              <a:t>}</a:t>
+              <a:t>await _txCol.doc(id).delete();</a:t>
             </a:r>
           </a:p>
         </p:txBody>

</xml_diff>

<commit_message>
Presentation: add screenshots and a Cloud Database (Firebase) slide
- Insert app screenshots into the title, solution and UI/UX slides
- Add a "Cloud Database — Firebase" slide pairing the app with the
  Firestore console (transactions collection) to show realtime cloud sync
- Remove the Profile references and the Live Demo slide
- Add docs/screenshots/firebase_console.png used by build_slides.py
</commit_message>
<xml_diff>
--- a/docs/My_Wallet_Presentation.pptx
+++ b/docs/My_Wallet_Presentation.pptx
@@ -3352,7 +3352,7 @@
                 </a:solidFill>
                 <a:latin typeface="Calibri"/>
               </a:rPr>
-              <a:t>DES3113 — Mobile App Design &amp; Development  ·  Pitch &amp; Demo</a:t>
+              <a:t>DES3113 — Mobile App Design &amp; Development  ·  Project Pitch</a:t>
             </a:r>
           </a:p>
           <a:p>
@@ -3424,16 +3424,45 @@
           </a:p>
         </p:txBody>
       </p:sp>
-      <p:sp>
-        <p:nvSpPr>
-          <p:cNvPr id="9" name="TextBox 8"/>
+      <p:pic>
+        <p:nvPicPr>
+          <p:cNvPr id="9" name="Picture 8" descr="01_ledger.png"/>
+          <p:cNvPicPr>
+            <a:picLocks noChangeAspect="1"/>
+          </p:cNvPicPr>
+          <p:nvPr/>
+        </p:nvPicPr>
+        <p:blipFill>
+          <a:blip r:embed="rId2"/>
+          <a:stretch>
+            <a:fillRect/>
+          </a:stretch>
+        </p:blipFill>
+        <p:spPr>
+          <a:xfrm>
+            <a:off x="8897524" y="1517904"/>
+            <a:ext cx="1681672" cy="3639311"/>
+          </a:xfrm>
+          <a:prstGeom prst="rect">
+            <a:avLst/>
+          </a:prstGeom>
+          <a:ln w="12700">
+            <a:solidFill>
+              <a:srgbClr val="FFC107"/>
+            </a:solidFill>
+          </a:ln>
+        </p:spPr>
+      </p:pic>
+      <p:sp>
+        <p:nvSpPr>
+          <p:cNvPr id="10" name="TextBox 9"/>
           <p:cNvSpPr txBox="1"/>
           <p:nvPr/>
         </p:nvSpPr>
         <p:spPr>
           <a:xfrm>
-            <a:off x="8229600" y="1371600"/>
-            <a:ext cx="3017520" cy="4206240"/>
+            <a:off x="8229600" y="5193792"/>
+            <a:ext cx="3017520" cy="310896"/>
           </a:xfrm>
           <a:prstGeom prst="rect">
             <a:avLst/>
@@ -3451,55 +3480,17 @@
                 <a:spcPts val="0"/>
               </a:spcBef>
               <a:spcAft>
-                <a:spcPts val="600"/>
-              </a:spcAft>
-            </a:pPr>
-            <a:r>
-              <a:rPr sz="3000" b="0" i="0">
-                <a:solidFill>
-                  <a:srgbClr val="FFC107"/>
+                <a:spcPts val="400"/>
+              </a:spcAft>
+            </a:pPr>
+            <a:r>
+              <a:rPr sz="1150" b="1" i="0">
+                <a:solidFill>
+                  <a:srgbClr val="FFFFFF"/>
                 </a:solidFill>
                 <a:latin typeface="Calibri"/>
               </a:rPr>
-              <a:t>🖼</a:t>
-            </a:r>
-          </a:p>
-          <a:p>
-            <a:pPr algn="ctr">
-              <a:spcBef>
-                <a:spcPts val="0"/>
-              </a:spcBef>
-              <a:spcAft>
-                <a:spcPts val="300"/>
-              </a:spcAft>
-            </a:pPr>
-            <a:r>
-              <a:rPr sz="1300" b="1" i="0">
-                <a:solidFill>
-                  <a:srgbClr val="FFFFFF"/>
-                </a:solidFill>
-                <a:latin typeface="Calibri"/>
-              </a:rPr>
-              <a:t>Ledger / Home</a:t>
-            </a:r>
-          </a:p>
-          <a:p>
-            <a:pPr algn="ctr">
-              <a:spcBef>
-                <a:spcPts val="0"/>
-              </a:spcBef>
-              <a:spcAft>
-                <a:spcPts val="400"/>
-              </a:spcAft>
-            </a:pPr>
-            <a:r>
-              <a:rPr sz="1000" b="0" i="1">
-                <a:solidFill>
-                  <a:srgbClr val="BDBDBD"/>
-                </a:solidFill>
-                <a:latin typeface="Calibri"/>
-              </a:rPr>
-              <a:t>[ insert screenshot ]</a:t>
+              <a:t>Ledger</a:t>
             </a:r>
           </a:p>
         </p:txBody>
@@ -3537,92 +3528,6 @@
             <a:avLst/>
           </a:prstGeom>
           <a:solidFill>
-            <a:srgbClr val="1E1E1E"/>
-          </a:solidFill>
-          <a:ln>
-            <a:noFill/>
-          </a:ln>
-          <a:effectLst/>
-        </p:spPr>
-        <p:style>
-          <a:lnRef idx="1">
-            <a:schemeClr val="accent1"/>
-          </a:lnRef>
-          <a:fillRef idx="3">
-            <a:schemeClr val="accent1"/>
-          </a:fillRef>
-          <a:effectRef idx="2">
-            <a:schemeClr val="accent1"/>
-          </a:effectRef>
-          <a:fontRef idx="minor">
-            <a:schemeClr val="lt1"/>
-          </a:fontRef>
-        </p:style>
-        <p:txBody>
-          <a:bodyPr rtlCol="0" anchor="ctr"/>
-          <a:lstStyle/>
-          <a:p>
-            <a:pPr algn="ctr"/>
-          </a:p>
-        </p:txBody>
-      </p:sp>
-      <p:sp>
-        <p:nvSpPr>
-          <p:cNvPr id="3" name="TextBox 2"/>
-          <p:cNvSpPr txBox="1"/>
-          <p:nvPr/>
-        </p:nvSpPr>
-        <p:spPr>
-          <a:xfrm>
-            <a:off x="822960" y="2148840"/>
-            <a:ext cx="7315200" cy="914400"/>
-          </a:xfrm>
-          <a:prstGeom prst="rect">
-            <a:avLst/>
-          </a:prstGeom>
-          <a:noFill/>
-        </p:spPr>
-        <p:txBody>
-          <a:bodyPr wrap="square" anchor="t" lIns="0" rIns="0" tIns="0" bIns="0">
-            <a:spAutoFit/>
-          </a:bodyPr>
-          <a:lstStyle/>
-          <a:p>
-            <a:pPr algn="l">
-              <a:spcBef>
-                <a:spcPts val="0"/>
-              </a:spcBef>
-              <a:spcAft>
-                <a:spcPts val="400"/>
-              </a:spcAft>
-            </a:pPr>
-            <a:r>
-              <a:rPr sz="4800" b="1" i="0">
-                <a:solidFill>
-                  <a:srgbClr val="FFC107"/>
-                </a:solidFill>
-                <a:latin typeface="Trebuchet MS"/>
-              </a:rPr>
-              <a:t>Live Demo</a:t>
-            </a:r>
-          </a:p>
-        </p:txBody>
-      </p:sp>
-      <p:sp>
-        <p:nvSpPr>
-          <p:cNvPr id="4" name="Rectangle 3"/>
-          <p:cNvSpPr/>
-          <p:nvPr/>
-        </p:nvSpPr>
-        <p:spPr>
-          <a:xfrm>
-            <a:off x="868680" y="3200400"/>
-            <a:ext cx="548640" cy="64008"/>
-          </a:xfrm>
-          <a:prstGeom prst="rect">
-            <a:avLst/>
-          </a:prstGeom>
-          <a:solidFill>
             <a:srgbClr val="FFFFFF"/>
           </a:solidFill>
           <a:ln>
@@ -3654,16 +3559,16 @@
       </p:sp>
       <p:sp>
         <p:nvSpPr>
-          <p:cNvPr id="5" name="Oval 4"/>
+          <p:cNvPr id="3" name="Rounded Rectangle 2"/>
           <p:cNvSpPr/>
           <p:nvPr/>
         </p:nvSpPr>
         <p:spPr>
           <a:xfrm>
-            <a:off x="868680" y="3520440"/>
-            <a:ext cx="384048" cy="384048"/>
-          </a:xfrm>
-          <a:prstGeom prst="ellipse">
+            <a:off x="777240" y="557784"/>
+            <a:ext cx="237744" cy="237744"/>
+          </a:xfrm>
+          <a:prstGeom prst="roundRect">
             <a:avLst/>
           </a:prstGeom>
           <a:solidFill>
@@ -3694,27 +3599,27 @@
           <a:p>
             <a:pPr algn="ctr"/>
             <a:r>
-              <a:rPr sz="1600" b="1">
-                <a:solidFill>
-                  <a:srgbClr val="222222"/>
+              <a:rPr sz="1800" b="1">
+                <a:solidFill>
+                  <a:srgbClr val="FFFFFF"/>
                 </a:solidFill>
                 <a:latin typeface="Trebuchet MS"/>
               </a:rPr>
-              <a:t>1</a:t>
-            </a:r>
-          </a:p>
-        </p:txBody>
-      </p:sp>
-      <p:sp>
-        <p:nvSpPr>
-          <p:cNvPr id="6" name="TextBox 5"/>
+              <a:t/>
+            </a:r>
+          </a:p>
+        </p:txBody>
+      </p:sp>
+      <p:sp>
+        <p:nvSpPr>
+          <p:cNvPr id="4" name="TextBox 3"/>
           <p:cNvSpPr txBox="1"/>
           <p:nvPr/>
         </p:nvSpPr>
         <p:spPr>
           <a:xfrm>
-            <a:off x="1417320" y="3520440"/>
-            <a:ext cx="6400800" cy="457200"/>
+            <a:off x="1188720" y="502920"/>
+            <a:ext cx="10515600" cy="731520"/>
           </a:xfrm>
           <a:prstGeom prst="rect">
             <a:avLst/>
@@ -3722,7 +3627,7 @@
           <a:noFill/>
         </p:spPr>
         <p:txBody>
-          <a:bodyPr wrap="square" anchor="ctr" lIns="0" rIns="0" tIns="0" bIns="0">
+          <a:bodyPr wrap="square" anchor="t" lIns="0" rIns="0" tIns="0" bIns="0">
             <a:spAutoFit/>
           </a:bodyPr>
           <a:lstStyle/>
@@ -3736,36 +3641,82 @@
               </a:spcAft>
             </a:pPr>
             <a:r>
-              <a:rPr sz="1600" b="0" i="0">
-                <a:solidFill>
-                  <a:srgbClr val="FFFFFF"/>
+              <a:rPr sz="3000" b="1" i="0">
+                <a:solidFill>
+                  <a:srgbClr val="222222"/>
+                </a:solidFill>
+                <a:latin typeface="Trebuchet MS"/>
+              </a:rPr>
+              <a:t>UI / UX Design</a:t>
+            </a:r>
+          </a:p>
+        </p:txBody>
+      </p:sp>
+      <p:sp>
+        <p:nvSpPr>
+          <p:cNvPr id="5" name="TextBox 4"/>
+          <p:cNvSpPr txBox="1"/>
+          <p:nvPr/>
+        </p:nvSpPr>
+        <p:spPr>
+          <a:xfrm>
+            <a:off x="822960" y="1371600"/>
+            <a:ext cx="10515600" cy="457200"/>
+          </a:xfrm>
+          <a:prstGeom prst="rect">
+            <a:avLst/>
+          </a:prstGeom>
+          <a:noFill/>
+        </p:spPr>
+        <p:txBody>
+          <a:bodyPr wrap="square" anchor="t" lIns="0" rIns="0" tIns="0" bIns="0">
+            <a:spAutoFit/>
+          </a:bodyPr>
+          <a:lstStyle/>
+          <a:p>
+            <a:pPr algn="l">
+              <a:spcBef>
+                <a:spcPts val="0"/>
+              </a:spcBef>
+              <a:spcAft>
+                <a:spcPts val="400"/>
+              </a:spcAft>
+            </a:pPr>
+            <a:r>
+              <a:rPr sz="1400" b="0" i="1">
+                <a:solidFill>
+                  <a:srgbClr val="6B6B6B"/>
                 </a:solidFill>
                 <a:latin typeface="Calibri"/>
               </a:rPr>
-              <a:t>Add an expense with the keypad</a:t>
-            </a:r>
-          </a:p>
-        </p:txBody>
-      </p:sp>
-      <p:sp>
-        <p:nvSpPr>
-          <p:cNvPr id="7" name="Oval 6"/>
+              <a:t>Material 3 · amber brand colour · familiar daily-ledger layout.</a:t>
+            </a:r>
+          </a:p>
+        </p:txBody>
+      </p:sp>
+      <p:sp>
+        <p:nvSpPr>
+          <p:cNvPr id="6" name="Rounded Rectangle 5"/>
           <p:cNvSpPr/>
           <p:nvPr/>
         </p:nvSpPr>
         <p:spPr>
           <a:xfrm>
-            <a:off x="868680" y="4123944"/>
-            <a:ext cx="384048" cy="384048"/>
-          </a:xfrm>
-          <a:prstGeom prst="ellipse">
-            <a:avLst/>
+            <a:off x="822960" y="1965960"/>
+            <a:ext cx="2542032" cy="3566160"/>
+          </a:xfrm>
+          <a:prstGeom prst="roundRect">
+            <a:avLst>
+              <a:gd name="adj" fmla="val 8000"/>
+            </a:avLst>
           </a:prstGeom>
           <a:solidFill>
-            <a:srgbClr val="FFC107"/>
+            <a:srgbClr val="F3F3F3"/>
           </a:solidFill>
-          <a:ln>
-            <a:noFill/>
+          <a:ln w="19050">
+            <a:solidFill>
+              <a:srgbClr val="D9D9D9"/>
+            </a:solidFill>
           </a:ln>
           <a:effectLst/>
         </p:spPr>
@@ -3784,22 +3735,42 @@
           </a:fontRef>
         </p:style>
         <p:txBody>
-          <a:bodyPr rtlCol="0" anchor="ctr" wrap="none" lIns="0" rIns="0" tIns="0" bIns="0"/>
+          <a:bodyPr rtlCol="0" anchor="ctr"/>
           <a:lstStyle/>
           <a:p>
             <a:pPr algn="ctr"/>
-            <a:r>
-              <a:rPr sz="1600" b="1">
-                <a:solidFill>
-                  <a:srgbClr val="222222"/>
-                </a:solidFill>
-                <a:latin typeface="Trebuchet MS"/>
-              </a:rPr>
-              <a:t>2</a:t>
-            </a:r>
-          </a:p>
-        </p:txBody>
-      </p:sp>
+          </a:p>
+        </p:txBody>
+      </p:sp>
+      <p:pic>
+        <p:nvPicPr>
+          <p:cNvPr id="7" name="Picture 6" descr="01_ledger.png"/>
+          <p:cNvPicPr>
+            <a:picLocks noChangeAspect="1"/>
+          </p:cNvPicPr>
+          <p:nvPr/>
+        </p:nvPicPr>
+        <p:blipFill>
+          <a:blip r:embed="rId2"/>
+          <a:stretch>
+            <a:fillRect/>
+          </a:stretch>
+        </p:blipFill>
+        <p:spPr>
+          <a:xfrm>
+            <a:off x="1401025" y="2112264"/>
+            <a:ext cx="1385901" cy="2999232"/>
+          </a:xfrm>
+          <a:prstGeom prst="rect">
+            <a:avLst/>
+          </a:prstGeom>
+          <a:ln w="12700">
+            <a:solidFill>
+              <a:srgbClr val="D9D9D9"/>
+            </a:solidFill>
+          </a:ln>
+        </p:spPr>
+      </p:pic>
       <p:sp>
         <p:nvSpPr>
           <p:cNvPr id="8" name="TextBox 7"/>
@@ -3808,8 +3779,8 @@
         </p:nvSpPr>
         <p:spPr>
           <a:xfrm>
-            <a:off x="1417320" y="4123944"/>
-            <a:ext cx="6400800" cy="457200"/>
+            <a:off x="822960" y="5148072"/>
+            <a:ext cx="2542032" cy="310896"/>
           </a:xfrm>
           <a:prstGeom prst="rect">
             <a:avLst/>
@@ -3822,7 +3793,7 @@
           </a:bodyPr>
           <a:lstStyle/>
           <a:p>
-            <a:pPr algn="l">
+            <a:pPr algn="ctr">
               <a:spcBef>
                 <a:spcPts val="0"/>
               </a:spcBef>
@@ -3831,36 +3802,40 @@
               </a:spcAft>
             </a:pPr>
             <a:r>
-              <a:rPr sz="1600" b="0" i="0">
-                <a:solidFill>
-                  <a:srgbClr val="FFFFFF"/>
+              <a:rPr sz="1150" b="1" i="0">
+                <a:solidFill>
+                  <a:srgbClr val="222222"/>
                 </a:solidFill>
                 <a:latin typeface="Calibri"/>
               </a:rPr>
-              <a:t>Watch it appear in today's ledger</a:t>
-            </a:r>
-          </a:p>
-        </p:txBody>
-      </p:sp>
-      <p:sp>
-        <p:nvSpPr>
-          <p:cNvPr id="9" name="Oval 8"/>
+              <a:t>Ledger</a:t>
+            </a:r>
+          </a:p>
+        </p:txBody>
+      </p:sp>
+      <p:sp>
+        <p:nvSpPr>
+          <p:cNvPr id="9" name="Rounded Rectangle 8"/>
           <p:cNvSpPr/>
           <p:nvPr/>
         </p:nvSpPr>
         <p:spPr>
           <a:xfrm>
-            <a:off x="868680" y="4727448"/>
-            <a:ext cx="384048" cy="384048"/>
-          </a:xfrm>
-          <a:prstGeom prst="ellipse">
-            <a:avLst/>
+            <a:off x="3584447" y="1965960"/>
+            <a:ext cx="2542032" cy="3566160"/>
+          </a:xfrm>
+          <a:prstGeom prst="roundRect">
+            <a:avLst>
+              <a:gd name="adj" fmla="val 8000"/>
+            </a:avLst>
           </a:prstGeom>
           <a:solidFill>
-            <a:srgbClr val="FFC107"/>
+            <a:srgbClr val="F3F3F3"/>
           </a:solidFill>
-          <a:ln>
-            <a:noFill/>
+          <a:ln w="19050">
+            <a:solidFill>
+              <a:srgbClr val="D9D9D9"/>
+            </a:solidFill>
           </a:ln>
           <a:effectLst/>
         </p:spPr>
@@ -3879,32 +3854,52 @@
           </a:fontRef>
         </p:style>
         <p:txBody>
-          <a:bodyPr rtlCol="0" anchor="ctr" wrap="none" lIns="0" rIns="0" tIns="0" bIns="0"/>
+          <a:bodyPr rtlCol="0" anchor="ctr"/>
           <a:lstStyle/>
           <a:p>
             <a:pPr algn="ctr"/>
-            <a:r>
-              <a:rPr sz="1600" b="1">
-                <a:solidFill>
-                  <a:srgbClr val="222222"/>
-                </a:solidFill>
-                <a:latin typeface="Trebuchet MS"/>
-              </a:rPr>
-              <a:t>3</a:t>
-            </a:r>
-          </a:p>
-        </p:txBody>
-      </p:sp>
-      <p:sp>
-        <p:nvSpPr>
-          <p:cNvPr id="10" name="TextBox 9"/>
+          </a:p>
+        </p:txBody>
+      </p:sp>
+      <p:pic>
+        <p:nvPicPr>
+          <p:cNvPr id="10" name="Picture 9" descr="02_add_record.png"/>
+          <p:cNvPicPr>
+            <a:picLocks noChangeAspect="1"/>
+          </p:cNvPicPr>
+          <p:nvPr/>
+        </p:nvPicPr>
+        <p:blipFill>
+          <a:blip r:embed="rId3"/>
+          <a:stretch>
+            <a:fillRect/>
+          </a:stretch>
+        </p:blipFill>
+        <p:spPr>
+          <a:xfrm>
+            <a:off x="4162512" y="2112264"/>
+            <a:ext cx="1385901" cy="2999232"/>
+          </a:xfrm>
+          <a:prstGeom prst="rect">
+            <a:avLst/>
+          </a:prstGeom>
+          <a:ln w="12700">
+            <a:solidFill>
+              <a:srgbClr val="D9D9D9"/>
+            </a:solidFill>
+          </a:ln>
+        </p:spPr>
+      </p:pic>
+      <p:sp>
+        <p:nvSpPr>
+          <p:cNvPr id="11" name="TextBox 10"/>
           <p:cNvSpPr txBox="1"/>
           <p:nvPr/>
         </p:nvSpPr>
         <p:spPr>
           <a:xfrm>
-            <a:off x="1417320" y="4727448"/>
-            <a:ext cx="6400800" cy="457200"/>
+            <a:off x="3584447" y="5148072"/>
+            <a:ext cx="2542032" cy="310896"/>
           </a:xfrm>
           <a:prstGeom prst="rect">
             <a:avLst/>
@@ -3917,7 +3912,7 @@
           </a:bodyPr>
           <a:lstStyle/>
           <a:p>
-            <a:pPr algn="l">
+            <a:pPr algn="ctr">
               <a:spcBef>
                 <a:spcPts val="0"/>
               </a:spcBef>
@@ -3926,36 +3921,40 @@
               </a:spcAft>
             </a:pPr>
             <a:r>
-              <a:rPr sz="1600" b="0" i="0">
-                <a:solidFill>
-                  <a:srgbClr val="FFFFFF"/>
+              <a:rPr sz="1150" b="1" i="0">
+                <a:solidFill>
+                  <a:srgbClr val="222222"/>
                 </a:solidFill>
                 <a:latin typeface="Calibri"/>
               </a:rPr>
-              <a:t>Open it, edit the amount, delete it</a:t>
-            </a:r>
-          </a:p>
-        </p:txBody>
-      </p:sp>
-      <p:sp>
-        <p:nvSpPr>
-          <p:cNvPr id="11" name="Oval 10"/>
+              <a:t>Add Record</a:t>
+            </a:r>
+          </a:p>
+        </p:txBody>
+      </p:sp>
+      <p:sp>
+        <p:nvSpPr>
+          <p:cNvPr id="12" name="Rounded Rectangle 11"/>
           <p:cNvSpPr/>
           <p:nvPr/>
         </p:nvSpPr>
         <p:spPr>
           <a:xfrm>
-            <a:off x="868680" y="5330952"/>
-            <a:ext cx="384048" cy="384048"/>
-          </a:xfrm>
-          <a:prstGeom prst="ellipse">
-            <a:avLst/>
+            <a:off x="6345936" y="1965960"/>
+            <a:ext cx="2542032" cy="3566160"/>
+          </a:xfrm>
+          <a:prstGeom prst="roundRect">
+            <a:avLst>
+              <a:gd name="adj" fmla="val 8000"/>
+            </a:avLst>
           </a:prstGeom>
           <a:solidFill>
-            <a:srgbClr val="FFC107"/>
+            <a:srgbClr val="F3F3F3"/>
           </a:solidFill>
-          <a:ln>
-            <a:noFill/>
+          <a:ln w="19050">
+            <a:solidFill>
+              <a:srgbClr val="D9D9D9"/>
+            </a:solidFill>
           </a:ln>
           <a:effectLst/>
         </p:spPr>
@@ -3974,32 +3973,52 @@
           </a:fontRef>
         </p:style>
         <p:txBody>
-          <a:bodyPr rtlCol="0" anchor="ctr" wrap="none" lIns="0" rIns="0" tIns="0" bIns="0"/>
+          <a:bodyPr rtlCol="0" anchor="ctr"/>
           <a:lstStyle/>
           <a:p>
             <a:pPr algn="ctr"/>
-            <a:r>
-              <a:rPr sz="1600" b="1">
-                <a:solidFill>
-                  <a:srgbClr val="222222"/>
-                </a:solidFill>
-                <a:latin typeface="Trebuchet MS"/>
-              </a:rPr>
-              <a:t>4</a:t>
-            </a:r>
-          </a:p>
-        </p:txBody>
-      </p:sp>
-      <p:sp>
-        <p:nvSpPr>
-          <p:cNvPr id="12" name="TextBox 11"/>
+          </a:p>
+        </p:txBody>
+      </p:sp>
+      <p:pic>
+        <p:nvPicPr>
+          <p:cNvPr id="13" name="Picture 12" descr="04_charts.png"/>
+          <p:cNvPicPr>
+            <a:picLocks noChangeAspect="1"/>
+          </p:cNvPicPr>
+          <p:nvPr/>
+        </p:nvPicPr>
+        <p:blipFill>
+          <a:blip r:embed="rId4"/>
+          <a:stretch>
+            <a:fillRect/>
+          </a:stretch>
+        </p:blipFill>
+        <p:spPr>
+          <a:xfrm>
+            <a:off x="6924001" y="2112264"/>
+            <a:ext cx="1385901" cy="2999232"/>
+          </a:xfrm>
+          <a:prstGeom prst="rect">
+            <a:avLst/>
+          </a:prstGeom>
+          <a:ln w="12700">
+            <a:solidFill>
+              <a:srgbClr val="D9D9D9"/>
+            </a:solidFill>
+          </a:ln>
+        </p:spPr>
+      </p:pic>
+      <p:sp>
+        <p:nvSpPr>
+          <p:cNvPr id="14" name="TextBox 13"/>
           <p:cNvSpPr txBox="1"/>
           <p:nvPr/>
         </p:nvSpPr>
         <p:spPr>
           <a:xfrm>
-            <a:off x="1417320" y="5330952"/>
-            <a:ext cx="6400800" cy="457200"/>
+            <a:off x="6345936" y="5148072"/>
+            <a:ext cx="2542032" cy="310896"/>
           </a:xfrm>
           <a:prstGeom prst="rect">
             <a:avLst/>
@@ -4012,7 +4031,7 @@
           </a:bodyPr>
           <a:lstStyle/>
           <a:p>
-            <a:pPr algn="l">
+            <a:pPr algn="ctr">
               <a:spcBef>
                 <a:spcPts val="0"/>
               </a:spcBef>
@@ -4021,27 +4040,27 @@
               </a:spcAft>
             </a:pPr>
             <a:r>
-              <a:rPr sz="1600" b="0" i="0">
-                <a:solidFill>
-                  <a:srgbClr val="FFFFFF"/>
+              <a:rPr sz="1150" b="1" i="0">
+                <a:solidFill>
+                  <a:srgbClr val="222222"/>
                 </a:solidFill>
                 <a:latin typeface="Calibri"/>
               </a:rPr>
-              <a:t>Set a budget · view the charts</a:t>
-            </a:r>
-          </a:p>
-        </p:txBody>
-      </p:sp>
-      <p:sp>
-        <p:nvSpPr>
-          <p:cNvPr id="13" name="Rounded Rectangle 12"/>
+              <a:t>Charts</a:t>
+            </a:r>
+          </a:p>
+        </p:txBody>
+      </p:sp>
+      <p:sp>
+        <p:nvSpPr>
+          <p:cNvPr id="15" name="Rounded Rectangle 14"/>
           <p:cNvSpPr/>
           <p:nvPr/>
         </p:nvSpPr>
         <p:spPr>
           <a:xfrm>
-            <a:off x="8595360" y="1554480"/>
-            <a:ext cx="2743200" cy="3749039"/>
+            <a:off x="9107424" y="1965960"/>
+            <a:ext cx="2542032" cy="3566160"/>
           </a:xfrm>
           <a:prstGeom prst="roundRect">
             <a:avLst>
@@ -4049,11 +4068,11 @@
             </a:avLst>
           </a:prstGeom>
           <a:solidFill>
-            <a:srgbClr val="2C2C2C"/>
+            <a:srgbClr val="F3F3F3"/>
           </a:solidFill>
           <a:ln w="19050">
             <a:solidFill>
-              <a:srgbClr val="FFC107"/>
+              <a:srgbClr val="D9D9D9"/>
             </a:solidFill>
           </a:ln>
           <a:effectLst/>
@@ -4080,16 +4099,45 @@
           </a:p>
         </p:txBody>
       </p:sp>
-      <p:sp>
-        <p:nvSpPr>
-          <p:cNvPr id="14" name="TextBox 13"/>
+      <p:pic>
+        <p:nvPicPr>
+          <p:cNvPr id="16" name="Picture 15" descr="05_discover.png"/>
+          <p:cNvPicPr>
+            <a:picLocks noChangeAspect="1"/>
+          </p:cNvPicPr>
+          <p:nvPr/>
+        </p:nvPicPr>
+        <p:blipFill>
+          <a:blip r:embed="rId5"/>
+          <a:stretch>
+            <a:fillRect/>
+          </a:stretch>
+        </p:blipFill>
+        <p:spPr>
+          <a:xfrm>
+            <a:off x="9685489" y="2112264"/>
+            <a:ext cx="1385901" cy="2999232"/>
+          </a:xfrm>
+          <a:prstGeom prst="rect">
+            <a:avLst/>
+          </a:prstGeom>
+          <a:ln w="12700">
+            <a:solidFill>
+              <a:srgbClr val="D9D9D9"/>
+            </a:solidFill>
+          </a:ln>
+        </p:spPr>
+      </p:pic>
+      <p:sp>
+        <p:nvSpPr>
+          <p:cNvPr id="17" name="TextBox 16"/>
           <p:cNvSpPr txBox="1"/>
           <p:nvPr/>
         </p:nvSpPr>
         <p:spPr>
           <a:xfrm>
-            <a:off x="8595360" y="1554480"/>
-            <a:ext cx="2743200" cy="3749039"/>
+            <a:off x="9107424" y="5148072"/>
+            <a:ext cx="2542032" cy="310896"/>
           </a:xfrm>
           <a:prstGeom prst="rect">
             <a:avLst/>
@@ -4107,55 +4155,17 @@
                 <a:spcPts val="0"/>
               </a:spcBef>
               <a:spcAft>
-                <a:spcPts val="600"/>
-              </a:spcAft>
-            </a:pPr>
-            <a:r>
-              <a:rPr sz="3000" b="0" i="0">
-                <a:solidFill>
-                  <a:srgbClr val="FFC107"/>
+                <a:spcPts val="400"/>
+              </a:spcAft>
+            </a:pPr>
+            <a:r>
+              <a:rPr sz="1150" b="1" i="0">
+                <a:solidFill>
+                  <a:srgbClr val="222222"/>
                 </a:solidFill>
                 <a:latin typeface="Calibri"/>
               </a:rPr>
-              <a:t>🖼</a:t>
-            </a:r>
-          </a:p>
-          <a:p>
-            <a:pPr algn="ctr">
-              <a:spcBef>
-                <a:spcPts val="0"/>
-              </a:spcBef>
-              <a:spcAft>
-                <a:spcPts val="300"/>
-              </a:spcAft>
-            </a:pPr>
-            <a:r>
-              <a:rPr sz="1300" b="1" i="0">
-                <a:solidFill>
-                  <a:srgbClr val="FFFFFF"/>
-                </a:solidFill>
-                <a:latin typeface="Calibri"/>
-              </a:rPr>
-              <a:t>App Demo</a:t>
-            </a:r>
-          </a:p>
-          <a:p>
-            <a:pPr algn="ctr">
-              <a:spcBef>
-                <a:spcPts val="0"/>
-              </a:spcBef>
-              <a:spcAft>
-                <a:spcPts val="400"/>
-              </a:spcAft>
-            </a:pPr>
-            <a:r>
-              <a:rPr sz="1000" b="0" i="1">
-                <a:solidFill>
-                  <a:srgbClr val="BDBDBD"/>
-                </a:solidFill>
-                <a:latin typeface="Calibri"/>
-              </a:rPr>
-              <a:t>[ insert screenshot ]</a:t>
+              <a:t>Discover</a:t>
             </a:r>
           </a:p>
         </p:txBody>
@@ -5833,7 +5843,7 @@
                 </a:solidFill>
                 <a:latin typeface="Calibri"/>
               </a:rPr>
-              <a:t>Discover, Profile · Firebase &amp; testing</a:t>
+              <a:t>Discover screen · Firebase &amp; testing</a:t>
             </a:r>
           </a:p>
         </p:txBody>
@@ -7384,7 +7394,7 @@
                 </a:solidFill>
                 <a:latin typeface="Calibri"/>
               </a:rPr>
-              <a:t>Questions &amp; demo  ·  github.com/LBBT-God/expense-tracker</a:t>
+              <a:t>Questions  ·  github.com/LBBT-God/expense-tracker</a:t>
             </a:r>
           </a:p>
         </p:txBody>
@@ -8810,16 +8820,45 @@
           </a:p>
         </p:txBody>
       </p:sp>
-      <p:sp>
-        <p:nvSpPr>
-          <p:cNvPr id="17" name="TextBox 16"/>
+      <p:pic>
+        <p:nvPicPr>
+          <p:cNvPr id="17" name="Picture 16" descr="05_discover.png"/>
+          <p:cNvPicPr>
+            <a:picLocks noChangeAspect="1"/>
+          </p:cNvPicPr>
+          <p:nvPr/>
+        </p:nvPicPr>
+        <p:blipFill>
+          <a:blip r:embed="rId2"/>
+          <a:stretch>
+            <a:fillRect/>
+          </a:stretch>
+        </p:blipFill>
+        <p:spPr>
+          <a:xfrm>
+            <a:off x="8876397" y="1563624"/>
+            <a:ext cx="1723926" cy="3730752"/>
+          </a:xfrm>
+          <a:prstGeom prst="rect">
+            <a:avLst/>
+          </a:prstGeom>
+          <a:ln w="12700">
+            <a:solidFill>
+              <a:srgbClr val="D9D9D9"/>
+            </a:solidFill>
+          </a:ln>
+        </p:spPr>
+      </p:pic>
+      <p:sp>
+        <p:nvSpPr>
+          <p:cNvPr id="18" name="TextBox 17"/>
           <p:cNvSpPr txBox="1"/>
           <p:nvPr/>
         </p:nvSpPr>
         <p:spPr>
           <a:xfrm>
-            <a:off x="8229600" y="1417320"/>
-            <a:ext cx="3017520" cy="4297680"/>
+            <a:off x="8229600" y="5330952"/>
+            <a:ext cx="3017520" cy="310896"/>
           </a:xfrm>
           <a:prstGeom prst="rect">
             <a:avLst/>
@@ -8837,55 +8876,17 @@
                 <a:spcPts val="0"/>
               </a:spcBef>
               <a:spcAft>
-                <a:spcPts val="600"/>
-              </a:spcAft>
-            </a:pPr>
-            <a:r>
-              <a:rPr sz="3000" b="0" i="0">
-                <a:solidFill>
-                  <a:srgbClr val="6B6B6B"/>
+                <a:spcPts val="400"/>
+              </a:spcAft>
+            </a:pPr>
+            <a:r>
+              <a:rPr sz="1150" b="1" i="0">
+                <a:solidFill>
+                  <a:srgbClr val="222222"/>
                 </a:solidFill>
                 <a:latin typeface="Calibri"/>
               </a:rPr>
-              <a:t>🖼</a:t>
-            </a:r>
-          </a:p>
-          <a:p>
-            <a:pPr algn="ctr">
-              <a:spcBef>
-                <a:spcPts val="0"/>
-              </a:spcBef>
-              <a:spcAft>
-                <a:spcPts val="300"/>
-              </a:spcAft>
-            </a:pPr>
-            <a:r>
-              <a:rPr sz="1300" b="1" i="0">
-                <a:solidFill>
-                  <a:srgbClr val="222222"/>
-                </a:solidFill>
-                <a:latin typeface="Calibri"/>
-              </a:rPr>
-              <a:t>My Wallet — Ledger</a:t>
-            </a:r>
-          </a:p>
-          <a:p>
-            <a:pPr algn="ctr">
-              <a:spcBef>
-                <a:spcPts val="0"/>
-              </a:spcBef>
-              <a:spcAft>
-                <a:spcPts val="400"/>
-              </a:spcAft>
-            </a:pPr>
-            <a:r>
-              <a:rPr sz="1000" b="0" i="1">
-                <a:solidFill>
-                  <a:srgbClr val="6B6B6B"/>
-                </a:solidFill>
-                <a:latin typeface="Calibri"/>
-              </a:rPr>
-              <a:t>[ insert screenshot ]</a:t>
+              <a:t>Budget &amp; Stats</a:t>
             </a:r>
           </a:p>
         </p:txBody>
@@ -9793,7 +9794,7 @@
                 </a:solidFill>
                 <a:latin typeface="Trebuchet MS"/>
               </a:rPr>
-              <a:t>👤</a:t>
+              <a:t>📈</a:t>
             </a:r>
           </a:p>
         </p:txBody>
@@ -11443,7 +11444,7 @@
                 </a:solidFill>
                 <a:latin typeface="Calibri"/>
               </a:rPr>
-              <a:t>Ledger · Charts · Discover · Profile · Add / Edit</a:t>
+              <a:t>Ledger · Charts · Record · Discover · Add / Edit</a:t>
             </a:r>
           </a:p>
         </p:txBody>
@@ -14141,7 +14142,7 @@
                 </a:solidFill>
                 <a:latin typeface="Trebuchet MS"/>
               </a:rPr>
-              <a:t>UI / UX Design</a:t>
+              <a:t>Cloud Database — Firebase</a:t>
             </a:r>
           </a:p>
         </p:txBody>
@@ -14183,7 +14184,7 @@
                 </a:solidFill>
                 <a:latin typeface="Calibri"/>
               </a:rPr>
-              <a:t>Material 3 · amber brand colour · familiar daily-ledger layout.</a:t>
+              <a:t>Every record is a document in Cloud Firestore — created, updated and deleted in realtime.</a:t>
             </a:r>
           </a:p>
         </p:txBody>
@@ -14196,8 +14197,8 @@
         </p:nvSpPr>
         <p:spPr>
           <a:xfrm>
-            <a:off x="822960" y="1965960"/>
-            <a:ext cx="2542032" cy="3566160"/>
+            <a:off x="822960" y="2011680"/>
+            <a:ext cx="2468880" cy="4023360"/>
           </a:xfrm>
           <a:prstGeom prst="roundRect">
             <a:avLst>
@@ -14236,16 +14237,45 @@
           </a:p>
         </p:txBody>
       </p:sp>
-      <p:sp>
-        <p:nvSpPr>
-          <p:cNvPr id="7" name="TextBox 6"/>
+      <p:pic>
+        <p:nvPicPr>
+          <p:cNvPr id="7" name="Picture 6" descr="01_ledger.png"/>
+          <p:cNvPicPr>
+            <a:picLocks noChangeAspect="1"/>
+          </p:cNvPicPr>
+          <p:nvPr/>
+        </p:nvPicPr>
+        <p:blipFill>
+          <a:blip r:embed="rId2"/>
+          <a:stretch>
+            <a:fillRect/>
+          </a:stretch>
+        </p:blipFill>
+        <p:spPr>
+          <a:xfrm>
+            <a:off x="1258817" y="2157984"/>
+            <a:ext cx="1597166" cy="3456432"/>
+          </a:xfrm>
+          <a:prstGeom prst="rect">
+            <a:avLst/>
+          </a:prstGeom>
+          <a:ln w="12700">
+            <a:solidFill>
+              <a:srgbClr val="D9D9D9"/>
+            </a:solidFill>
+          </a:ln>
+        </p:spPr>
+      </p:pic>
+      <p:sp>
+        <p:nvSpPr>
+          <p:cNvPr id="8" name="TextBox 7"/>
           <p:cNvSpPr txBox="1"/>
           <p:nvPr/>
         </p:nvSpPr>
         <p:spPr>
           <a:xfrm>
-            <a:off x="822960" y="1965960"/>
-            <a:ext cx="2542032" cy="3566160"/>
+            <a:off x="822960" y="5650992"/>
+            <a:ext cx="2468880" cy="310896"/>
           </a:xfrm>
           <a:prstGeom prst="rect">
             <a:avLst/>
@@ -14263,82 +14293,40 @@
                 <a:spcPts val="0"/>
               </a:spcBef>
               <a:spcAft>
-                <a:spcPts val="600"/>
-              </a:spcAft>
-            </a:pPr>
-            <a:r>
-              <a:rPr sz="3000" b="0" i="0">
-                <a:solidFill>
-                  <a:srgbClr val="6B6B6B"/>
+                <a:spcPts val="400"/>
+              </a:spcAft>
+            </a:pPr>
+            <a:r>
+              <a:rPr sz="1150" b="1" i="0">
+                <a:solidFill>
+                  <a:srgbClr val="222222"/>
                 </a:solidFill>
                 <a:latin typeface="Calibri"/>
               </a:rPr>
-              <a:t>🖼</a:t>
-            </a:r>
-          </a:p>
-          <a:p>
-            <a:pPr algn="ctr">
-              <a:spcBef>
-                <a:spcPts val="0"/>
-              </a:spcBef>
-              <a:spcAft>
-                <a:spcPts val="300"/>
-              </a:spcAft>
-            </a:pPr>
-            <a:r>
-              <a:rPr sz="1300" b="1" i="0">
-                <a:solidFill>
-                  <a:srgbClr val="222222"/>
-                </a:solidFill>
-                <a:latin typeface="Calibri"/>
-              </a:rPr>
-              <a:t>Ledger</a:t>
-            </a:r>
-          </a:p>
-          <a:p>
-            <a:pPr algn="ctr">
-              <a:spcBef>
-                <a:spcPts val="0"/>
-              </a:spcBef>
-              <a:spcAft>
-                <a:spcPts val="400"/>
-              </a:spcAft>
-            </a:pPr>
-            <a:r>
-              <a:rPr sz="1000" b="0" i="1">
-                <a:solidFill>
-                  <a:srgbClr val="6B6B6B"/>
-                </a:solidFill>
-                <a:latin typeface="Calibri"/>
-              </a:rPr>
-              <a:t>[ insert screenshot ]</a:t>
-            </a:r>
-          </a:p>
-        </p:txBody>
-      </p:sp>
-      <p:sp>
-        <p:nvSpPr>
-          <p:cNvPr id="8" name="Rounded Rectangle 7"/>
+              <a:t>App · Ledger</a:t>
+            </a:r>
+          </a:p>
+        </p:txBody>
+      </p:sp>
+      <p:sp>
+        <p:nvSpPr>
+          <p:cNvPr id="9" name="Oval 8"/>
           <p:cNvSpPr/>
           <p:nvPr/>
         </p:nvSpPr>
         <p:spPr>
           <a:xfrm>
-            <a:off x="3584447" y="1965960"/>
-            <a:ext cx="2542032" cy="3566160"/>
-          </a:xfrm>
-          <a:prstGeom prst="roundRect">
-            <a:avLst>
-              <a:gd name="adj" fmla="val 8000"/>
-            </a:avLst>
+            <a:off x="3611880" y="3520440"/>
+            <a:ext cx="868680" cy="868680"/>
+          </a:xfrm>
+          <a:prstGeom prst="ellipse">
+            <a:avLst/>
           </a:prstGeom>
           <a:solidFill>
-            <a:srgbClr val="F3F3F3"/>
+            <a:srgbClr val="FFC107"/>
           </a:solidFill>
-          <a:ln w="19050">
-            <a:solidFill>
-              <a:srgbClr val="D9D9D9"/>
-            </a:solidFill>
+          <a:ln>
+            <a:noFill/>
           </a:ln>
           <a:effectLst/>
         </p:spPr>
@@ -14357,23 +14345,32 @@
           </a:fontRef>
         </p:style>
         <p:txBody>
-          <a:bodyPr rtlCol="0" anchor="ctr"/>
+          <a:bodyPr rtlCol="0" anchor="ctr" wrap="none" lIns="0" rIns="0" tIns="0" bIns="0"/>
           <a:lstStyle/>
           <a:p>
             <a:pPr algn="ctr"/>
-          </a:p>
-        </p:txBody>
-      </p:sp>
-      <p:sp>
-        <p:nvSpPr>
-          <p:cNvPr id="9" name="TextBox 8"/>
+            <a:r>
+              <a:rPr sz="2600" b="1">
+                <a:solidFill>
+                  <a:srgbClr val="222222"/>
+                </a:solidFill>
+                <a:latin typeface="Trebuchet MS"/>
+              </a:rPr>
+              <a:t>🔄</a:t>
+            </a:r>
+          </a:p>
+        </p:txBody>
+      </p:sp>
+      <p:sp>
+        <p:nvSpPr>
+          <p:cNvPr id="10" name="TextBox 9"/>
           <p:cNvSpPr txBox="1"/>
           <p:nvPr/>
         </p:nvSpPr>
         <p:spPr>
           <a:xfrm>
-            <a:off x="3584447" y="1965960"/>
-            <a:ext cx="2542032" cy="3566160"/>
+            <a:off x="3200400" y="4526280"/>
+            <a:ext cx="1691640" cy="457200"/>
           </a:xfrm>
           <a:prstGeom prst="rect">
             <a:avLst/>
@@ -14381,7 +14378,7 @@
           <a:noFill/>
         </p:spPr>
         <p:txBody>
-          <a:bodyPr wrap="square" anchor="ctr" lIns="0" rIns="0" tIns="0" bIns="0">
+          <a:bodyPr wrap="square" anchor="t" lIns="0" rIns="0" tIns="0" bIns="0">
             <a:spAutoFit/>
           </a:bodyPr>
           <a:lstStyle/>
@@ -14391,311 +14388,167 @@
                 <a:spcPts val="0"/>
               </a:spcBef>
               <a:spcAft>
-                <a:spcPts val="600"/>
-              </a:spcAft>
-            </a:pPr>
-            <a:r>
-              <a:rPr sz="3000" b="0" i="0">
-                <a:solidFill>
-                  <a:srgbClr val="6B6B6B"/>
+                <a:spcPts val="400"/>
+              </a:spcAft>
+            </a:pPr>
+            <a:r>
+              <a:rPr sz="1150" b="1" i="0">
+                <a:solidFill>
+                  <a:srgbClr val="222222"/>
                 </a:solidFill>
                 <a:latin typeface="Calibri"/>
               </a:rPr>
-              <a:t>🖼</a:t>
-            </a:r>
-          </a:p>
+              <a:t>Realtime sync</a:t>
+            </a:r>
+          </a:p>
+        </p:txBody>
+      </p:sp>
+      <p:pic>
+        <p:nvPicPr>
+          <p:cNvPr id="11" name="Picture 10" descr="firebase_console.png"/>
+          <p:cNvPicPr>
+            <a:picLocks noChangeAspect="1"/>
+          </p:cNvPicPr>
+          <p:nvPr/>
+        </p:nvPicPr>
+        <p:blipFill>
+          <a:blip r:embed="rId3"/>
+          <a:stretch>
+            <a:fillRect/>
+          </a:stretch>
+        </p:blipFill>
+        <p:spPr>
+          <a:xfrm>
+            <a:off x="4800600" y="2148840"/>
+            <a:ext cx="6812280" cy="2948279"/>
+          </a:xfrm>
+          <a:prstGeom prst="rect">
+            <a:avLst/>
+          </a:prstGeom>
+          <a:ln w="12700">
+            <a:solidFill>
+              <a:srgbClr val="D9D9D9"/>
+            </a:solidFill>
+          </a:ln>
+        </p:spPr>
+      </p:pic>
+      <p:sp>
+        <p:nvSpPr>
+          <p:cNvPr id="12" name="TextBox 11"/>
+          <p:cNvSpPr txBox="1"/>
+          <p:nvPr/>
+        </p:nvSpPr>
+        <p:spPr>
+          <a:xfrm>
+            <a:off x="4800600" y="5169754"/>
+            <a:ext cx="6812280" cy="320040"/>
+          </a:xfrm>
+          <a:prstGeom prst="rect">
+            <a:avLst/>
+          </a:prstGeom>
+          <a:noFill/>
+        </p:spPr>
+        <p:txBody>
+          <a:bodyPr wrap="square" anchor="t" lIns="0" rIns="0" tIns="0" bIns="0">
+            <a:spAutoFit/>
+          </a:bodyPr>
+          <a:lstStyle/>
           <a:p>
             <a:pPr algn="ctr">
               <a:spcBef>
                 <a:spcPts val="0"/>
               </a:spcBef>
               <a:spcAft>
-                <a:spcPts val="300"/>
-              </a:spcAft>
-            </a:pPr>
-            <a:r>
-              <a:rPr sz="1300" b="1" i="0">
-                <a:solidFill>
-                  <a:srgbClr val="222222"/>
+                <a:spcPts val="400"/>
+              </a:spcAft>
+            </a:pPr>
+            <a:r>
+              <a:rPr sz="1100" b="0" i="1">
+                <a:solidFill>
+                  <a:srgbClr val="6B6B6B"/>
                 </a:solidFill>
                 <a:latin typeface="Calibri"/>
               </a:rPr>
-              <a:t>Add Record</a:t>
-            </a:r>
-          </a:p>
-          <a:p>
-            <a:pPr algn="ctr">
+              <a:t>Cloud Firestore · project des3113-7d1fe · transactions collection</a:t>
+            </a:r>
+          </a:p>
+        </p:txBody>
+      </p:sp>
+      <p:sp>
+        <p:nvSpPr>
+          <p:cNvPr id="13" name="TextBox 12"/>
+          <p:cNvSpPr txBox="1"/>
+          <p:nvPr/>
+        </p:nvSpPr>
+        <p:spPr>
+          <a:xfrm>
+            <a:off x="4800600" y="5532120"/>
+            <a:ext cx="6812280" cy="914400"/>
+          </a:xfrm>
+          <a:prstGeom prst="rect">
+            <a:avLst/>
+          </a:prstGeom>
+          <a:noFill/>
+        </p:spPr>
+        <p:txBody>
+          <a:bodyPr wrap="square" anchor="t" lIns="0" rIns="0" tIns="0" bIns="0">
+            <a:spAutoFit/>
+          </a:bodyPr>
+          <a:lstStyle/>
+          <a:p>
+            <a:pPr algn="l">
               <a:spcBef>
                 <a:spcPts val="0"/>
               </a:spcBef>
               <a:spcAft>
-                <a:spcPts val="400"/>
-              </a:spcAft>
-            </a:pPr>
-            <a:r>
-              <a:rPr sz="1000" b="0" i="1">
+                <a:spcPts val="600"/>
+              </a:spcAft>
+            </a:pPr>
+            <a:r>
+              <a:rPr sz="1200" b="1" i="0">
+                <a:solidFill>
+                  <a:srgbClr val="222222"/>
+                </a:solidFill>
+                <a:latin typeface="Calibri"/>
+              </a:rPr>
+              <a:t>transactions</a:t>
+            </a:r>
+            <a:r>
+              <a:rPr sz="1200" b="0" i="0">
                 <a:solidFill>
                   <a:srgbClr val="6B6B6B"/>
                 </a:solidFill>
                 <a:latin typeface="Calibri"/>
               </a:rPr>
-              <a:t>[ insert screenshot ]</a:t>
-            </a:r>
-          </a:p>
-        </p:txBody>
-      </p:sp>
-      <p:sp>
-        <p:nvSpPr>
-          <p:cNvPr id="10" name="Rounded Rectangle 9"/>
-          <p:cNvSpPr/>
-          <p:nvPr/>
-        </p:nvSpPr>
-        <p:spPr>
-          <a:xfrm>
-            <a:off x="6345936" y="1965960"/>
-            <a:ext cx="2542032" cy="3566160"/>
-          </a:xfrm>
-          <a:prstGeom prst="roundRect">
-            <a:avLst>
-              <a:gd name="adj" fmla="val 8000"/>
-            </a:avLst>
-          </a:prstGeom>
-          <a:solidFill>
-            <a:srgbClr val="F3F3F3"/>
-          </a:solidFill>
-          <a:ln w="19050">
-            <a:solidFill>
-              <a:srgbClr val="D9D9D9"/>
-            </a:solidFill>
-          </a:ln>
-          <a:effectLst/>
-        </p:spPr>
-        <p:style>
-          <a:lnRef idx="1">
-            <a:schemeClr val="accent1"/>
-          </a:lnRef>
-          <a:fillRef idx="3">
-            <a:schemeClr val="accent1"/>
-          </a:fillRef>
-          <a:effectRef idx="2">
-            <a:schemeClr val="accent1"/>
-          </a:effectRef>
-          <a:fontRef idx="minor">
-            <a:schemeClr val="lt1"/>
-          </a:fontRef>
-        </p:style>
-        <p:txBody>
-          <a:bodyPr rtlCol="0" anchor="ctr"/>
-          <a:lstStyle/>
-          <a:p>
-            <a:pPr algn="ctr"/>
-          </a:p>
-        </p:txBody>
-      </p:sp>
-      <p:sp>
-        <p:nvSpPr>
-          <p:cNvPr id="11" name="TextBox 10"/>
-          <p:cNvSpPr txBox="1"/>
-          <p:nvPr/>
-        </p:nvSpPr>
-        <p:spPr>
-          <a:xfrm>
-            <a:off x="6345936" y="1965960"/>
-            <a:ext cx="2542032" cy="3566160"/>
-          </a:xfrm>
-          <a:prstGeom prst="rect">
-            <a:avLst/>
-          </a:prstGeom>
-          <a:noFill/>
-        </p:spPr>
-        <p:txBody>
-          <a:bodyPr wrap="square" anchor="ctr" lIns="0" rIns="0" tIns="0" bIns="0">
-            <a:spAutoFit/>
-          </a:bodyPr>
-          <a:lstStyle/>
-          <a:p>
-            <a:pPr algn="ctr">
+              <a:t>  — one document per record; Create/Update via set(), Delete via delete().</a:t>
+            </a:r>
+          </a:p>
+          <a:p>
+            <a:pPr algn="l">
               <a:spcBef>
                 <a:spcPts val="0"/>
               </a:spcBef>
               <a:spcAft>
-                <a:spcPts val="600"/>
-              </a:spcAft>
-            </a:pPr>
-            <a:r>
-              <a:rPr sz="3000" b="0" i="0">
+                <a:spcPts val="400"/>
+              </a:spcAft>
+            </a:pPr>
+            <a:r>
+              <a:rPr sz="1200" b="1" i="0">
+                <a:solidFill>
+                  <a:srgbClr val="222222"/>
+                </a:solidFill>
+                <a:latin typeface="Calibri"/>
+              </a:rPr>
+              <a:t>Fields</a:t>
+            </a:r>
+            <a:r>
+              <a:rPr sz="1200" b="0" i="0">
                 <a:solidFill>
                   <a:srgbClr val="6B6B6B"/>
                 </a:solidFill>
                 <a:latin typeface="Calibri"/>
               </a:rPr>
-              <a:t>🖼</a:t>
-            </a:r>
-          </a:p>
-          <a:p>
-            <a:pPr algn="ctr">
-              <a:spcBef>
-                <a:spcPts val="0"/>
-              </a:spcBef>
-              <a:spcAft>
-                <a:spcPts val="300"/>
-              </a:spcAft>
-            </a:pPr>
-            <a:r>
-              <a:rPr sz="1300" b="1" i="0">
-                <a:solidFill>
-                  <a:srgbClr val="222222"/>
-                </a:solidFill>
-                <a:latin typeface="Calibri"/>
-              </a:rPr>
-              <a:t>Charts</a:t>
-            </a:r>
-          </a:p>
-          <a:p>
-            <a:pPr algn="ctr">
-              <a:spcBef>
-                <a:spcPts val="0"/>
-              </a:spcBef>
-              <a:spcAft>
-                <a:spcPts val="400"/>
-              </a:spcAft>
-            </a:pPr>
-            <a:r>
-              <a:rPr sz="1000" b="0" i="1">
-                <a:solidFill>
-                  <a:srgbClr val="6B6B6B"/>
-                </a:solidFill>
-                <a:latin typeface="Calibri"/>
-              </a:rPr>
-              <a:t>[ insert screenshot ]</a:t>
-            </a:r>
-          </a:p>
-        </p:txBody>
-      </p:sp>
-      <p:sp>
-        <p:nvSpPr>
-          <p:cNvPr id="12" name="Rounded Rectangle 11"/>
-          <p:cNvSpPr/>
-          <p:nvPr/>
-        </p:nvSpPr>
-        <p:spPr>
-          <a:xfrm>
-            <a:off x="9107424" y="1965960"/>
-            <a:ext cx="2542032" cy="3566160"/>
-          </a:xfrm>
-          <a:prstGeom prst="roundRect">
-            <a:avLst>
-              <a:gd name="adj" fmla="val 8000"/>
-            </a:avLst>
-          </a:prstGeom>
-          <a:solidFill>
-            <a:srgbClr val="F3F3F3"/>
-          </a:solidFill>
-          <a:ln w="19050">
-            <a:solidFill>
-              <a:srgbClr val="D9D9D9"/>
-            </a:solidFill>
-          </a:ln>
-          <a:effectLst/>
-        </p:spPr>
-        <p:style>
-          <a:lnRef idx="1">
-            <a:schemeClr val="accent1"/>
-          </a:lnRef>
-          <a:fillRef idx="3">
-            <a:schemeClr val="accent1"/>
-          </a:fillRef>
-          <a:effectRef idx="2">
-            <a:schemeClr val="accent1"/>
-          </a:effectRef>
-          <a:fontRef idx="minor">
-            <a:schemeClr val="lt1"/>
-          </a:fontRef>
-        </p:style>
-        <p:txBody>
-          <a:bodyPr rtlCol="0" anchor="ctr"/>
-          <a:lstStyle/>
-          <a:p>
-            <a:pPr algn="ctr"/>
-          </a:p>
-        </p:txBody>
-      </p:sp>
-      <p:sp>
-        <p:nvSpPr>
-          <p:cNvPr id="13" name="TextBox 12"/>
-          <p:cNvSpPr txBox="1"/>
-          <p:nvPr/>
-        </p:nvSpPr>
-        <p:spPr>
-          <a:xfrm>
-            <a:off x="9107424" y="1965960"/>
-            <a:ext cx="2542032" cy="3566160"/>
-          </a:xfrm>
-          <a:prstGeom prst="rect">
-            <a:avLst/>
-          </a:prstGeom>
-          <a:noFill/>
-        </p:spPr>
-        <p:txBody>
-          <a:bodyPr wrap="square" anchor="ctr" lIns="0" rIns="0" tIns="0" bIns="0">
-            <a:spAutoFit/>
-          </a:bodyPr>
-          <a:lstStyle/>
-          <a:p>
-            <a:pPr algn="ctr">
-              <a:spcBef>
-                <a:spcPts val="0"/>
-              </a:spcBef>
-              <a:spcAft>
-                <a:spcPts val="600"/>
-              </a:spcAft>
-            </a:pPr>
-            <a:r>
-              <a:rPr sz="3000" b="0" i="0">
-                <a:solidFill>
-                  <a:srgbClr val="6B6B6B"/>
-                </a:solidFill>
-                <a:latin typeface="Calibri"/>
-              </a:rPr>
-              <a:t>🖼</a:t>
-            </a:r>
-          </a:p>
-          <a:p>
-            <a:pPr algn="ctr">
-              <a:spcBef>
-                <a:spcPts val="0"/>
-              </a:spcBef>
-              <a:spcAft>
-                <a:spcPts val="300"/>
-              </a:spcAft>
-            </a:pPr>
-            <a:r>
-              <a:rPr sz="1300" b="1" i="0">
-                <a:solidFill>
-                  <a:srgbClr val="222222"/>
-                </a:solidFill>
-                <a:latin typeface="Calibri"/>
-              </a:rPr>
-              <a:t>Profile</a:t>
-            </a:r>
-          </a:p>
-          <a:p>
-            <a:pPr algn="ctr">
-              <a:spcBef>
-                <a:spcPts val="0"/>
-              </a:spcBef>
-              <a:spcAft>
-                <a:spcPts val="400"/>
-              </a:spcAft>
-            </a:pPr>
-            <a:r>
-              <a:rPr sz="1000" b="0" i="1">
-                <a:solidFill>
-                  <a:srgbClr val="6B6B6B"/>
-                </a:solidFill>
-                <a:latin typeface="Calibri"/>
-              </a:rPr>
-              <a:t>[ insert screenshot ]</a:t>
+              <a:t>  — amount · category · type · date · title · note, mirroring the model.</a:t>
             </a:r>
           </a:p>
         </p:txBody>

</xml_diff>